<commit_message>
Fix final pitch exports asset rendering
</commit_message>
<xml_diff>
--- a/public/pitch/gonggajido-final-pitch/final/gonggajido-final-pitch-pages.pptx
+++ b/public/pitch/gonggajido-final-pitch/final/gonggajido-final-pitch-pages.pptx
@@ -2,24 +2,24 @@
 <file path=ppt/presentation.xml><?xml version="1.0" encoding="utf-8"?>
 <p:presentation xmlns:p="http://schemas.openxmlformats.org/presentationml/2006/main">
   <p:sldMasterIdLst>
-    <p:sldMasterId xmlns:r="http://schemas.openxmlformats.org/officeDocument/2006/relationships" id="2147483648" r:id="R8f17216d926c4524"/>
+    <p:sldMasterId xmlns:r="http://schemas.openxmlformats.org/officeDocument/2006/relationships" id="2147483648" r:id="R1c435001182041e5"/>
   </p:sldMasterIdLst>
   <p:notesMasterIdLst>
-    <p:notesMasterId xmlns:r="http://schemas.openxmlformats.org/officeDocument/2006/relationships" r:id="R0db90f35c823414c"/>
+    <p:notesMasterId xmlns:r="http://schemas.openxmlformats.org/officeDocument/2006/relationships" r:id="R411bfee07e95402e"/>
   </p:notesMasterIdLst>
   <p:sldIdLst>
-    <p:sldId xmlns:r="http://schemas.openxmlformats.org/officeDocument/2006/relationships" id="256" r:id="R5cade4ebfa024435"/>
-    <p:sldId xmlns:r="http://schemas.openxmlformats.org/officeDocument/2006/relationships" id="257" r:id="R02592e056ae447cd"/>
-    <p:sldId xmlns:r="http://schemas.openxmlformats.org/officeDocument/2006/relationships" id="258" r:id="R886df9b666ae4f40"/>
-    <p:sldId xmlns:r="http://schemas.openxmlformats.org/officeDocument/2006/relationships" id="259" r:id="R4a41ab960b364f3c"/>
-    <p:sldId xmlns:r="http://schemas.openxmlformats.org/officeDocument/2006/relationships" id="260" r:id="R9e5a91cc45a04615"/>
-    <p:sldId xmlns:r="http://schemas.openxmlformats.org/officeDocument/2006/relationships" id="261" r:id="R555d2ad722f0410d"/>
-    <p:sldId xmlns:r="http://schemas.openxmlformats.org/officeDocument/2006/relationships" id="262" r:id="R138d6c0843e84a38"/>
-    <p:sldId xmlns:r="http://schemas.openxmlformats.org/officeDocument/2006/relationships" id="263" r:id="R565c67bbf6864255"/>
-    <p:sldId xmlns:r="http://schemas.openxmlformats.org/officeDocument/2006/relationships" id="264" r:id="Rb000c54a48ef43ab"/>
-    <p:sldId xmlns:r="http://schemas.openxmlformats.org/officeDocument/2006/relationships" id="265" r:id="R394cb038e7cc4c4f"/>
-    <p:sldId xmlns:r="http://schemas.openxmlformats.org/officeDocument/2006/relationships" id="266" r:id="R45164a9c65fd43d9"/>
-    <p:sldId xmlns:r="http://schemas.openxmlformats.org/officeDocument/2006/relationships" id="267" r:id="Rc359516935e34e93"/>
+    <p:sldId xmlns:r="http://schemas.openxmlformats.org/officeDocument/2006/relationships" id="256" r:id="Rfc25419376914564"/>
+    <p:sldId xmlns:r="http://schemas.openxmlformats.org/officeDocument/2006/relationships" id="257" r:id="Rd676a8c30ba8491d"/>
+    <p:sldId xmlns:r="http://schemas.openxmlformats.org/officeDocument/2006/relationships" id="258" r:id="R62eff2fbceaf48c1"/>
+    <p:sldId xmlns:r="http://schemas.openxmlformats.org/officeDocument/2006/relationships" id="259" r:id="R198c89c196df49ea"/>
+    <p:sldId xmlns:r="http://schemas.openxmlformats.org/officeDocument/2006/relationships" id="260" r:id="Rd42210aecad447a5"/>
+    <p:sldId xmlns:r="http://schemas.openxmlformats.org/officeDocument/2006/relationships" id="261" r:id="Rd4814a7020b2430f"/>
+    <p:sldId xmlns:r="http://schemas.openxmlformats.org/officeDocument/2006/relationships" id="262" r:id="Ref0cddc5a2ea4a8f"/>
+    <p:sldId xmlns:r="http://schemas.openxmlformats.org/officeDocument/2006/relationships" id="263" r:id="R05657479566c4ddc"/>
+    <p:sldId xmlns:r="http://schemas.openxmlformats.org/officeDocument/2006/relationships" id="264" r:id="R4a5aee3487bc4dbc"/>
+    <p:sldId xmlns:r="http://schemas.openxmlformats.org/officeDocument/2006/relationships" id="265" r:id="R90ff06d755a14a44"/>
+    <p:sldId xmlns:r="http://schemas.openxmlformats.org/officeDocument/2006/relationships" id="266" r:id="Rc42f957bdab14269"/>
+    <p:sldId xmlns:r="http://schemas.openxmlformats.org/officeDocument/2006/relationships" id="267" r:id="Rec7d9237027c48be"/>
   </p:sldIdLst>
   <p:sldSz cx="18288000" cy="10287000"/>
   <p:notesSz cx="6858000" cy="9144000"/>
@@ -1338,7 +1338,7 @@
   </p:cSld>
   <p:clrMap bg1="lt1" tx1="dk1" bg2="lt2" tx2="dk2" accent1="accent1" accent2="accent2" accent3="accent3" accent4="accent4" accent5="accent5" accent6="accent6" hlink="hlink" folHlink="folHlink"/>
   <p:sldLayoutIdLst>
-    <p:sldLayoutId xmlns:r="http://schemas.openxmlformats.org/officeDocument/2006/relationships" id="2147483649" r:id="R69360fe7efc247f5"/>
+    <p:sldLayoutId xmlns:r="http://schemas.openxmlformats.org/officeDocument/2006/relationships" id="2147483649" r:id="Rba85d5087be14717"/>
   </p:sldLayoutIdLst>
   <p:txStyles>
     <p:titleStyle>
@@ -1893,7 +1893,7 @@
           <p:nvPr/>
         </p:nvPicPr>
         <p:blipFill>
-          <a:blip xmlns:r="http://schemas.openxmlformats.org/officeDocument/2006/relationships" xmlns:a="http://schemas.openxmlformats.org/drawingml/2006/main" r:embed="Re4de3585164d4e4c"/>
+          <a:blip xmlns:r="http://schemas.openxmlformats.org/officeDocument/2006/relationships" xmlns:a="http://schemas.openxmlformats.org/drawingml/2006/main" r:embed="R08809ee91c404e84"/>
           <a:srcRect xmlns:a="http://schemas.openxmlformats.org/drawingml/2006/main" l="0" t="0" r="0" b="0"/>
           <a:stretch xmlns:a="http://schemas.openxmlformats.org/drawingml/2006/main">
             <a:fillRect l="0" t="0" r="0" b="0"/>
@@ -1912,7 +1912,7 @@
     </p:spTree>
     <p:extLst>
       <p:ext uri="{BB962C8B-B14F-4D97-AF65-F5344CB8AC3E}">
-        <p14:creationId xmlns:p14="http://schemas.microsoft.com/office/powerpoint/2010/main" val="1763416166"/>
+        <p14:creationId xmlns:p14="http://schemas.microsoft.com/office/powerpoint/2010/main" val="1436347626"/>
       </p:ext>
     </p:extLst>
   </p:cSld>
@@ -1947,7 +1947,7 @@
           <p:nvPr/>
         </p:nvPicPr>
         <p:blipFill>
-          <a:blip xmlns:r="http://schemas.openxmlformats.org/officeDocument/2006/relationships" xmlns:a="http://schemas.openxmlformats.org/drawingml/2006/main" r:embed="Rd749fc85c9504aff"/>
+          <a:blip xmlns:r="http://schemas.openxmlformats.org/officeDocument/2006/relationships" xmlns:a="http://schemas.openxmlformats.org/drawingml/2006/main" r:embed="Rafbc39538a584e90"/>
           <a:srcRect xmlns:a="http://schemas.openxmlformats.org/drawingml/2006/main" l="0" t="0" r="0" b="0"/>
           <a:stretch xmlns:a="http://schemas.openxmlformats.org/drawingml/2006/main">
             <a:fillRect l="0" t="0" r="0" b="0"/>
@@ -1966,7 +1966,7 @@
     </p:spTree>
     <p:extLst>
       <p:ext uri="{BB962C8B-B14F-4D97-AF65-F5344CB8AC3E}">
-        <p14:creationId xmlns:p14="http://schemas.microsoft.com/office/powerpoint/2010/main" val="1549414080"/>
+        <p14:creationId xmlns:p14="http://schemas.microsoft.com/office/powerpoint/2010/main" val="1724914335"/>
       </p:ext>
     </p:extLst>
   </p:cSld>
@@ -2001,7 +2001,7 @@
           <p:nvPr/>
         </p:nvPicPr>
         <p:blipFill>
-          <a:blip xmlns:r="http://schemas.openxmlformats.org/officeDocument/2006/relationships" xmlns:a="http://schemas.openxmlformats.org/drawingml/2006/main" r:embed="Re3b21a4491904669"/>
+          <a:blip xmlns:r="http://schemas.openxmlformats.org/officeDocument/2006/relationships" xmlns:a="http://schemas.openxmlformats.org/drawingml/2006/main" r:embed="Rebd384ed25e04141"/>
           <a:srcRect xmlns:a="http://schemas.openxmlformats.org/drawingml/2006/main" l="0" t="0" r="0" b="0"/>
           <a:stretch xmlns:a="http://schemas.openxmlformats.org/drawingml/2006/main">
             <a:fillRect l="0" t="0" r="0" b="0"/>
@@ -2020,7 +2020,7 @@
     </p:spTree>
     <p:extLst>
       <p:ext uri="{BB962C8B-B14F-4D97-AF65-F5344CB8AC3E}">
-        <p14:creationId xmlns:p14="http://schemas.microsoft.com/office/powerpoint/2010/main" val="1852528878"/>
+        <p14:creationId xmlns:p14="http://schemas.microsoft.com/office/powerpoint/2010/main" val="546394750"/>
       </p:ext>
     </p:extLst>
   </p:cSld>
@@ -2055,7 +2055,7 @@
           <p:nvPr/>
         </p:nvPicPr>
         <p:blipFill>
-          <a:blip xmlns:r="http://schemas.openxmlformats.org/officeDocument/2006/relationships" xmlns:a="http://schemas.openxmlformats.org/drawingml/2006/main" r:embed="R01051d0649dc4567"/>
+          <a:blip xmlns:r="http://schemas.openxmlformats.org/officeDocument/2006/relationships" xmlns:a="http://schemas.openxmlformats.org/drawingml/2006/main" r:embed="R8e6b31a8ac9a49c4"/>
           <a:srcRect xmlns:a="http://schemas.openxmlformats.org/drawingml/2006/main" l="0" t="0" r="0" b="0"/>
           <a:stretch xmlns:a="http://schemas.openxmlformats.org/drawingml/2006/main">
             <a:fillRect l="0" t="0" r="0" b="0"/>
@@ -2074,7 +2074,7 @@
     </p:spTree>
     <p:extLst>
       <p:ext uri="{BB962C8B-B14F-4D97-AF65-F5344CB8AC3E}">
-        <p14:creationId xmlns:p14="http://schemas.microsoft.com/office/powerpoint/2010/main" val="1553253340"/>
+        <p14:creationId xmlns:p14="http://schemas.microsoft.com/office/powerpoint/2010/main" val="613866949"/>
       </p:ext>
     </p:extLst>
   </p:cSld>
@@ -2109,7 +2109,7 @@
           <p:nvPr/>
         </p:nvPicPr>
         <p:blipFill>
-          <a:blip xmlns:r="http://schemas.openxmlformats.org/officeDocument/2006/relationships" xmlns:a="http://schemas.openxmlformats.org/drawingml/2006/main" r:embed="R42b01f954412464f"/>
+          <a:blip xmlns:r="http://schemas.openxmlformats.org/officeDocument/2006/relationships" xmlns:a="http://schemas.openxmlformats.org/drawingml/2006/main" r:embed="Rba9926a6fa944c71"/>
           <a:srcRect xmlns:a="http://schemas.openxmlformats.org/drawingml/2006/main" l="0" t="0" r="0" b="0"/>
           <a:stretch xmlns:a="http://schemas.openxmlformats.org/drawingml/2006/main">
             <a:fillRect l="0" t="0" r="0" b="0"/>
@@ -2128,7 +2128,7 @@
     </p:spTree>
     <p:extLst>
       <p:ext uri="{BB962C8B-B14F-4D97-AF65-F5344CB8AC3E}">
-        <p14:creationId xmlns:p14="http://schemas.microsoft.com/office/powerpoint/2010/main" val="382290170"/>
+        <p14:creationId xmlns:p14="http://schemas.microsoft.com/office/powerpoint/2010/main" val="1374392072"/>
       </p:ext>
     </p:extLst>
   </p:cSld>
@@ -2163,7 +2163,7 @@
           <p:nvPr/>
         </p:nvPicPr>
         <p:blipFill>
-          <a:blip xmlns:r="http://schemas.openxmlformats.org/officeDocument/2006/relationships" xmlns:a="http://schemas.openxmlformats.org/drawingml/2006/main" r:embed="R699464e6b7094a29"/>
+          <a:blip xmlns:r="http://schemas.openxmlformats.org/officeDocument/2006/relationships" xmlns:a="http://schemas.openxmlformats.org/drawingml/2006/main" r:embed="R71946f03b96742f0"/>
           <a:srcRect xmlns:a="http://schemas.openxmlformats.org/drawingml/2006/main" l="0" t="0" r="0" b="0"/>
           <a:stretch xmlns:a="http://schemas.openxmlformats.org/drawingml/2006/main">
             <a:fillRect l="0" t="0" r="0" b="0"/>
@@ -2182,7 +2182,7 @@
     </p:spTree>
     <p:extLst>
       <p:ext uri="{BB962C8B-B14F-4D97-AF65-F5344CB8AC3E}">
-        <p14:creationId xmlns:p14="http://schemas.microsoft.com/office/powerpoint/2010/main" val="1107329659"/>
+        <p14:creationId xmlns:p14="http://schemas.microsoft.com/office/powerpoint/2010/main" val="1470438054"/>
       </p:ext>
     </p:extLst>
   </p:cSld>
@@ -2217,7 +2217,7 @@
           <p:nvPr/>
         </p:nvPicPr>
         <p:blipFill>
-          <a:blip xmlns:r="http://schemas.openxmlformats.org/officeDocument/2006/relationships" xmlns:a="http://schemas.openxmlformats.org/drawingml/2006/main" r:embed="R85d8ab5709b547a3"/>
+          <a:blip xmlns:r="http://schemas.openxmlformats.org/officeDocument/2006/relationships" xmlns:a="http://schemas.openxmlformats.org/drawingml/2006/main" r:embed="Ra089d9e466864892"/>
           <a:srcRect xmlns:a="http://schemas.openxmlformats.org/drawingml/2006/main" l="0" t="0" r="0" b="0"/>
           <a:stretch xmlns:a="http://schemas.openxmlformats.org/drawingml/2006/main">
             <a:fillRect l="0" t="0" r="0" b="0"/>
@@ -2236,7 +2236,7 @@
     </p:spTree>
     <p:extLst>
       <p:ext uri="{BB962C8B-B14F-4D97-AF65-F5344CB8AC3E}">
-        <p14:creationId xmlns:p14="http://schemas.microsoft.com/office/powerpoint/2010/main" val="1761570935"/>
+        <p14:creationId xmlns:p14="http://schemas.microsoft.com/office/powerpoint/2010/main" val="1614739404"/>
       </p:ext>
     </p:extLst>
   </p:cSld>
@@ -2271,7 +2271,7 @@
           <p:nvPr/>
         </p:nvPicPr>
         <p:blipFill>
-          <a:blip xmlns:r="http://schemas.openxmlformats.org/officeDocument/2006/relationships" xmlns:a="http://schemas.openxmlformats.org/drawingml/2006/main" r:embed="Rf9b8930d267943a8"/>
+          <a:blip xmlns:r="http://schemas.openxmlformats.org/officeDocument/2006/relationships" xmlns:a="http://schemas.openxmlformats.org/drawingml/2006/main" r:embed="Rd4bf54ba06a3499c"/>
           <a:srcRect xmlns:a="http://schemas.openxmlformats.org/drawingml/2006/main" l="0" t="0" r="0" b="0"/>
           <a:stretch xmlns:a="http://schemas.openxmlformats.org/drawingml/2006/main">
             <a:fillRect l="0" t="0" r="0" b="0"/>
@@ -2290,7 +2290,7 @@
     </p:spTree>
     <p:extLst>
       <p:ext uri="{BB962C8B-B14F-4D97-AF65-F5344CB8AC3E}">
-        <p14:creationId xmlns:p14="http://schemas.microsoft.com/office/powerpoint/2010/main" val="489925999"/>
+        <p14:creationId xmlns:p14="http://schemas.microsoft.com/office/powerpoint/2010/main" val="1601977809"/>
       </p:ext>
     </p:extLst>
   </p:cSld>
@@ -2325,7 +2325,7 @@
           <p:nvPr/>
         </p:nvPicPr>
         <p:blipFill>
-          <a:blip xmlns:r="http://schemas.openxmlformats.org/officeDocument/2006/relationships" xmlns:a="http://schemas.openxmlformats.org/drawingml/2006/main" r:embed="Rc18c57373b194cb0"/>
+          <a:blip xmlns:r="http://schemas.openxmlformats.org/officeDocument/2006/relationships" xmlns:a="http://schemas.openxmlformats.org/drawingml/2006/main" r:embed="Rb4b0e0b488554992"/>
           <a:srcRect xmlns:a="http://schemas.openxmlformats.org/drawingml/2006/main" l="0" t="0" r="0" b="0"/>
           <a:stretch xmlns:a="http://schemas.openxmlformats.org/drawingml/2006/main">
             <a:fillRect l="0" t="0" r="0" b="0"/>
@@ -2344,7 +2344,7 @@
     </p:spTree>
     <p:extLst>
       <p:ext uri="{BB962C8B-B14F-4D97-AF65-F5344CB8AC3E}">
-        <p14:creationId xmlns:p14="http://schemas.microsoft.com/office/powerpoint/2010/main" val="1134499180"/>
+        <p14:creationId xmlns:p14="http://schemas.microsoft.com/office/powerpoint/2010/main" val="1529942728"/>
       </p:ext>
     </p:extLst>
   </p:cSld>
@@ -2379,7 +2379,7 @@
           <p:nvPr/>
         </p:nvPicPr>
         <p:blipFill>
-          <a:blip xmlns:r="http://schemas.openxmlformats.org/officeDocument/2006/relationships" xmlns:a="http://schemas.openxmlformats.org/drawingml/2006/main" r:embed="Rcabe2c059dab4503"/>
+          <a:blip xmlns:r="http://schemas.openxmlformats.org/officeDocument/2006/relationships" xmlns:a="http://schemas.openxmlformats.org/drawingml/2006/main" r:embed="Ra89736f99de8491d"/>
           <a:srcRect xmlns:a="http://schemas.openxmlformats.org/drawingml/2006/main" l="0" t="0" r="0" b="0"/>
           <a:stretch xmlns:a="http://schemas.openxmlformats.org/drawingml/2006/main">
             <a:fillRect l="0" t="0" r="0" b="0"/>
@@ -2398,7 +2398,7 @@
     </p:spTree>
     <p:extLst>
       <p:ext uri="{BB962C8B-B14F-4D97-AF65-F5344CB8AC3E}">
-        <p14:creationId xmlns:p14="http://schemas.microsoft.com/office/powerpoint/2010/main" val="1362467870"/>
+        <p14:creationId xmlns:p14="http://schemas.microsoft.com/office/powerpoint/2010/main" val="337774880"/>
       </p:ext>
     </p:extLst>
   </p:cSld>
@@ -2433,7 +2433,7 @@
           <p:nvPr/>
         </p:nvPicPr>
         <p:blipFill>
-          <a:blip xmlns:r="http://schemas.openxmlformats.org/officeDocument/2006/relationships" xmlns:a="http://schemas.openxmlformats.org/drawingml/2006/main" r:embed="R3d3a5a7f4607491c"/>
+          <a:blip xmlns:r="http://schemas.openxmlformats.org/officeDocument/2006/relationships" xmlns:a="http://schemas.openxmlformats.org/drawingml/2006/main" r:embed="R441cecc0e4e04a27"/>
           <a:srcRect xmlns:a="http://schemas.openxmlformats.org/drawingml/2006/main" l="0" t="0" r="0" b="0"/>
           <a:stretch xmlns:a="http://schemas.openxmlformats.org/drawingml/2006/main">
             <a:fillRect l="0" t="0" r="0" b="0"/>
@@ -2452,7 +2452,7 @@
     </p:spTree>
     <p:extLst>
       <p:ext uri="{BB962C8B-B14F-4D97-AF65-F5344CB8AC3E}">
-        <p14:creationId xmlns:p14="http://schemas.microsoft.com/office/powerpoint/2010/main" val="2036491990"/>
+        <p14:creationId xmlns:p14="http://schemas.microsoft.com/office/powerpoint/2010/main" val="1338992385"/>
       </p:ext>
     </p:extLst>
   </p:cSld>
@@ -2487,7 +2487,7 @@
           <p:nvPr/>
         </p:nvPicPr>
         <p:blipFill>
-          <a:blip xmlns:r="http://schemas.openxmlformats.org/officeDocument/2006/relationships" xmlns:a="http://schemas.openxmlformats.org/drawingml/2006/main" r:embed="R0fe47fb05aa247aa"/>
+          <a:blip xmlns:r="http://schemas.openxmlformats.org/officeDocument/2006/relationships" xmlns:a="http://schemas.openxmlformats.org/drawingml/2006/main" r:embed="R0c006350de1441a3"/>
           <a:srcRect xmlns:a="http://schemas.openxmlformats.org/drawingml/2006/main" l="0" t="0" r="0" b="0"/>
           <a:stretch xmlns:a="http://schemas.openxmlformats.org/drawingml/2006/main">
             <a:fillRect l="0" t="0" r="0" b="0"/>
@@ -2506,7 +2506,7 @@
     </p:spTree>
     <p:extLst>
       <p:ext uri="{BB962C8B-B14F-4D97-AF65-F5344CB8AC3E}">
-        <p14:creationId xmlns:p14="http://schemas.microsoft.com/office/powerpoint/2010/main" val="1174098138"/>
+        <p14:creationId xmlns:p14="http://schemas.microsoft.com/office/powerpoint/2010/main" val="2032771396"/>
       </p:ext>
     </p:extLst>
   </p:cSld>

</xml_diff>